<commit_message>
Remove personal names — curriculum now fully generic
Replace all occurrences of student/teacher names with
'Student' and 'Teacher' throughout all lessons, labs,
assignments, and generator scripts.

Metadata headers use placeholders: *(your name)* and
*(your student's name)* for easy personalisation.

Co-Authored-By: Claude Sonnet 4.6 <noreply@anthropic.com>
</commit_message>
<xml_diff>
--- a/curriculum_advaith.pptx
+++ b/curriculum_advaith.pptx
@@ -3417,7 +3417,7 @@
                   <a:srgbClr val="CCCCDD"/>
                 </a:solidFill>
               </a:rPr>
-              <a:t>Advaith's</a:t>
+              <a:t>2-Month</a:t>
             </a:r>
           </a:p>
         </p:txBody>
@@ -3596,7 +3596,7 @@
                   <a:srgbClr val="FFFFFF"/>
                 </a:solidFill>
               </a:rPr>
-              <a:t>Advaith</a:t>
+              <a:t>—</a:t>
             </a:r>
           </a:p>
         </p:txBody>
@@ -3664,7 +3664,7 @@
                   <a:srgbClr val="FFFFFF"/>
                 </a:solidFill>
               </a:rPr>
-              <a:t>Sree</a:t>
+              <a:t>—</a:t>
             </a:r>
           </a:p>
         </p:txBody>
@@ -3868,7 +3868,7 @@
                   <a:srgbClr val="888899"/>
                 </a:solidFill>
               </a:rPr>
-              <a:t>Taught by Sree  ·  Built for NITW M&amp;C  ·  Starting from zero</a:t>
+              <a:t>Taught by Teacher ·  Built for NITW M&amp;C  ·  Starting from zero</a:t>
             </a:r>
           </a:p>
         </p:txBody>
@@ -7215,7 +7215,7 @@
                   <a:srgbClr val="FFFFFF"/>
                 </a:solidFill>
               </a:rPr>
-              <a:t>1.  Research 5 computing milestones (Sree provides starting points)</a:t>
+              <a:t>1.  Research 5 computing milestones (Teacher provides starting points)</a:t>
             </a:r>
           </a:p>
           <a:p>
@@ -7230,7 +7230,7 @@
                   <a:srgbClr val="FFFFFF"/>
                 </a:solidFill>
               </a:rPr>
-              <a:t>2.  Research 5 sports analytics milestones (Advaith finds these)</a:t>
+              <a:t>2.  Research 5 sports analytics milestones (Student finds these)</a:t>
             </a:r>
           </a:p>
           <a:p>
@@ -7260,7 +7260,7 @@
                   <a:srgbClr val="FFFFFF"/>
                 </a:solidFill>
               </a:rPr>
-              <a:t>4.  Present the sports milestones to Sree — explain each one</a:t>
+              <a:t>4.  Present the sports milestones to Teacher — explain each one</a:t>
             </a:r>
           </a:p>
         </p:txBody>
@@ -7414,7 +7414,7 @@
                   <a:srgbClr val="FFFFFF"/>
                 </a:solidFill>
               </a:rPr>
-              <a:t>A 10-row table: half computing, half sports. Advaith presents his 5 sports milestones aloud.</a:t>
+              <a:t>A 10-row table: half computing, half sports. Student presents his 5 sports milestones aloud.</a:t>
             </a:r>
           </a:p>
         </p:txBody>
@@ -8306,7 +8306,7 @@
                   <a:srgbClr val="CCCCDD"/>
                 </a:solidFill>
               </a:rPr>
-              <a:t>Sree: show the electron microscope die shot of an Apple M3 chip. Let it land silently for 5 seconds.</a:t>
+              <a:t>Teacher: show the electron microscope die shot of an Apple M3 chip. Let it land silently for 5 seconds.</a:t>
             </a:r>
           </a:p>
         </p:txBody>
@@ -8935,7 +8935,7 @@
               </a:rPr>
               <a:t>Every decision a computer makes — every if/else in every app ever written — reduces to these three operations.
 AND, OR, NOT are Boolean algebra.
-Advaith already knows this from 12th-grade set theory:
+Student already knows this from 12th-grade set theory:
 AND = ∩
 OR = ∪
 NOT = complement</a:t>
@@ -10986,7 +10986,7 @@
                   <a:srgbClr val="FFFFFF"/>
                 </a:solidFill>
               </a:rPr>
-              <a:t>👨‍🏫  Sree teaches every session. Advaith practices independently after each.</a:t>
+              <a:t>👨‍🏫  Teacher teaches every session. Student practices independently after each.</a:t>
             </a:r>
           </a:p>
           <a:p>
@@ -11046,7 +11046,7 @@
                   <a:srgbClr val="FFFFFF"/>
                 </a:solidFill>
               </a:rPr>
-              <a:t>🏆  Ends with a real, working capstone project Advaith presents himself</a:t>
+              <a:t>🏆  Ends with a real, working capstone project Student presents himself</a:t>
             </a:r>
           </a:p>
         </p:txBody>
@@ -11784,7 +11784,7 @@
                   <a:srgbClr val="CCCCDD"/>
                 </a:solidFill>
               </a:rPr>
-              <a:t>Ask Advaith: 'What's your phone number in this analogy?' Answer: your device's IP address.</a:t>
+              <a:t>Ask Student: 'What's your phone number in this analogy?' Answer: your device's IP address.</a:t>
             </a:r>
           </a:p>
         </p:txBody>
@@ -13054,7 +13054,7 @@
                   <a:srgbClr val="FFFFFF"/>
                 </a:solidFill>
               </a:rPr>
-              <a:t>▸  The dark theme on Advaith's sports page</a:t>
+              <a:t>▸  The dark theme on the student's sports page</a:t>
             </a:r>
           </a:p>
           <a:p>
@@ -14123,7 +14123,7 @@
                   <a:srgbClr val="FFFFFF"/>
                 </a:solidFill>
               </a:rPr>
-              <a:t>2.  Replace all players with Advaith's actual favourites</a:t>
+              <a:t>2.  Replace all players with the student's actual favourites</a:t>
             </a:r>
           </a:p>
           <a:p>
@@ -16416,7 +16416,7 @@
                   <a:srgbClr val="FFFFFF"/>
                 </a:solidFill>
               </a:rPr>
-              <a:t>Who Is Advaith?</a:t>
+              <a:t>Student Profile</a:t>
             </a:r>
           </a:p>
         </p:txBody>
@@ -17332,7 +17332,7 @@
                   <a:srgbClr val="CCCCDD"/>
                 </a:solidFill>
               </a:rPr>
-              <a:t>Sree: 'Google's PageRank algorithm that made them $100B is betweenness centrality on the web's link graph. Invented in 1956, used for billions of searches today.'</a:t>
+              <a:t>Teacher: 'Google's PageRank algorithm that made them $100B is betweenness centrality on the web's link graph. Invented in 1956, used for billions of searches today.'</a:t>
             </a:r>
           </a:p>
         </p:txBody>
@@ -18443,7 +18443,7 @@
                   <a:srgbClr val="FFFFFF"/>
                 </a:solidFill>
               </a:rPr>
-              <a:t>5.  Send Sree an encrypted message — see if he can decode it</a:t>
+              <a:t>5.  Send Teacher an encrypted message — see if he can decode it</a:t>
             </a:r>
           </a:p>
         </p:txBody>
@@ -18598,7 +18598,7 @@
                 </a:solidFill>
               </a:rPr>
               <a:t>encrypt() and decrypt() functions working.
-Send Sree a real secret message.</a:t>
+Send Teacher a real secret message.</a:t>
             </a:r>
           </a:p>
         </p:txBody>
@@ -18752,7 +18752,7 @@
                   <a:srgbClr val="FFFFFF"/>
                 </a:solidFill>
               </a:rPr>
-              <a:t>Encrypt 'ADVAITH WILL ACE NITW' and send it to Sree</a:t>
+              <a:t>Encrypt 'ADVAITH WILL ACE NITW' and send it to Teacher</a:t>
             </a:r>
           </a:p>
         </p:txBody>
@@ -23530,7 +23530,7 @@
                   <a:srgbClr val="FFFFFF"/>
                 </a:solidFill>
               </a:rPr>
-              <a:t>🎬  HOOK — Sree opens with a story or demo that creates a question</a:t>
+              <a:t>🎬  HOOK — Teacher opens with a story or demo that creates a question</a:t>
             </a:r>
           </a:p>
           <a:p>
@@ -23545,7 +23545,7 @@
                   <a:srgbClr val="FFFFFF"/>
                 </a:solidFill>
               </a:rPr>
-              <a:t>📖  EXPLAIN — Sree walks through the concept live, no slides-only lectures</a:t>
+              <a:t>📖  EXPLAIN — Teacher walks through the concept live, no slides-only lectures</a:t>
             </a:r>
           </a:p>
           <a:p>
@@ -23560,7 +23560,7 @@
                   <a:srgbClr val="FFFFFF"/>
                 </a:solidFill>
               </a:rPr>
-              <a:t>🔧  DEMO — Sree runs real code or a visualisation</a:t>
+              <a:t>🔧  DEMO — Teacher runs real code or a visualisation</a:t>
             </a:r>
           </a:p>
           <a:p>
@@ -23575,7 +23575,7 @@
                   <a:srgbClr val="FFFFFF"/>
                 </a:solidFill>
               </a:rPr>
-              <a:t>🤝  PRACTICE — Sree and Advaith build it together</a:t>
+              <a:t>🤝  PRACTICE — Teacher and Student build it together</a:t>
             </a:r>
           </a:p>
           <a:p>
@@ -23605,7 +23605,7 @@
                   <a:srgbClr val="FFFFFF"/>
                 </a:solidFill>
               </a:rPr>
-              <a:t>📝  HOMEWORK — Advaith continues independently before the next session</a:t>
+              <a:t>📝  HOMEWORK — Student continues independently before the next session</a:t>
             </a:r>
           </a:p>
         </p:txBody>
@@ -23725,7 +23725,7 @@
                   <a:srgbClr val="CCCCDD"/>
                 </a:solidFill>
               </a:rPr>
-              <a:t>Rule: no session starts with 'today we learn X'. Every session starts with something that makes Advaith want to understand X.</a:t>
+              <a:t>Rule: no session starts with 'today we learn X'. Every session starts with something that makes Student want to understand X.</a:t>
             </a:r>
           </a:p>
         </p:txBody>
@@ -26956,7 +26956,7 @@
                   <a:srgbClr val="FFFFFF"/>
                 </a:solidFill>
               </a:rPr>
-              <a:t>5.  Sree explains: this is O(log n) — 1,000 numbers in 10 guesses</a:t>
+              <a:t>5.  Teacher explains: this is O(log n) — 1,000 numbers in 10 guesses</a:t>
             </a:r>
           </a:p>
         </p:txBody>
@@ -27870,7 +27870,7 @@
                 </a:solidFill>
               </a:rPr>
               <a:t>Two charts saved as top_scorers.png
-Advaith's own favourite players, his own data.
+the student's own favourite players, his own data.
 Send it to friends — it looks professional.</a:t>
             </a:r>
           </a:p>
@@ -30446,7 +30446,7 @@
                   <a:srgbClr val="FFFFFF"/>
                 </a:solidFill>
               </a:rPr>
-              <a:t>✅  Advaith already knows vectors from 12th-grade physics. He already knows matrix multiplication.</a:t>
+              <a:t>✅  Student already knows vectors from 12th-grade physics. He already knows matrix multiplication.</a:t>
             </a:r>
           </a:p>
         </p:txBody>
@@ -36615,7 +36615,7 @@
                   <a:srgbClr val="CCCCDD"/>
                 </a:solidFill>
               </a:rPr>
-              <a:t>AI that reasons, uses tools, takes actions · The era Advaith enters</a:t>
+              <a:t>AI that reasons, uses tools, takes actions · The era Student enters</a:t>
             </a:r>
           </a:p>
         </p:txBody>
@@ -44018,7 +44018,7 @@
                   <a:srgbClr val="FFFFFF"/>
                 </a:solidFill>
               </a:rPr>
-              <a:t>✅  Every single symbol in Black-Scholes is something Advaith already knows from 12th grade</a:t>
+              <a:t>✅  Every single symbol in Black-Scholes is something Student already knows from 12th grade</a:t>
             </a:r>
           </a:p>
           <a:p>
@@ -44168,7 +44168,7 @@
                   <a:srgbClr val="CCCCDD"/>
                 </a:solidFill>
               </a:rPr>
-              <a:t>Sree: write the Black-Scholes formula on a whiteboard. Point to each symbol. 'You know this. This. And this. All of it.' This is the moment.</a:t>
+              <a:t>Teacher: write the Black-Scholes formula on a whiteboard. Point to each symbol. 'You know this. This. And this. All of it.' This is the moment.</a:t>
             </a:r>
           </a:p>
         </p:txBody>
@@ -47449,7 +47449,7 @@
                   <a:srgbClr val="CCCCDD"/>
                 </a:solidFill>
               </a:rPr>
-              <a:t>This is the hardest track. But if Advaith can explain how a neural network learns from scratch, he understands something most CS graduates can't.</a:t>
+              <a:t>This is the hardest track. But if Student can explain how a neural network learns from scratch, he understands something most CS graduates can't.</a:t>
             </a:r>
           </a:p>
         </p:txBody>
@@ -47870,7 +47870,7 @@
                   <a:srgbClr val="CCCCDD"/>
                 </a:solidFill>
               </a:rPr>
-              <a:t>Meta-moment: Advaith is building a system that does what Sree has been doing. The student builds the teacher.</a:t>
+              <a:t>Meta-moment: Student is building a system that does what Teacher has been doing. The student builds the teacher.</a:t>
             </a:r>
           </a:p>
         </p:txBody>
@@ -48291,7 +48291,7 @@
                   <a:srgbClr val="CCCCDD"/>
                 </a:solidFill>
               </a:rPr>
-              <a:t>Starter file: sports_dashboard_starter.py — skeleton with empty functions. Advaith fills them in using what he learned.</a:t>
+              <a:t>Starter file: sports_dashboard_starter.py — skeleton with empty functions. Student fills them in using what he learned.</a:t>
             </a:r>
           </a:p>
         </p:txBody>
@@ -48637,7 +48637,7 @@
                   <a:srgbClr val="FFFFFF"/>
                 </a:solidFill>
               </a:rPr>
-              <a:t>▸  Day 1–2: Scope and scaffold with Sree</a:t>
+              <a:t>▸  Day 1–2: Scope and scaffold with Teacher</a:t>
             </a:r>
           </a:p>
           <a:p>
@@ -48667,7 +48667,7 @@
                   <a:srgbClr val="FFFFFF"/>
                 </a:solidFill>
               </a:rPr>
-              <a:t>▸  → Advaith leaves with something that runs (even if empty)</a:t>
+              <a:t>▸  → Student leaves with something that runs (even if empty)</a:t>
             </a:r>
           </a:p>
           <a:p>
@@ -48682,7 +48682,7 @@
                   <a:srgbClr val="FFFFFF"/>
                 </a:solidFill>
               </a:rPr>
-              <a:t>▸  Day 3–5: Advaith builds independently</a:t>
+              <a:t>▸  Day 3–5: Student builds independently</a:t>
             </a:r>
           </a:p>
           <a:p>
@@ -48697,7 +48697,7 @@
                   <a:srgbClr val="FFFFFF"/>
                 </a:solidFill>
               </a:rPr>
-              <a:t>▸  → Sree available to unblock — NOT to write code</a:t>
+              <a:t>▸  → Teacher available to unblock — NOT to write code</a:t>
             </a:r>
           </a:p>
           <a:p>
@@ -48727,7 +48727,7 @@
                   <a:srgbClr val="FFFFFF"/>
                 </a:solidFill>
               </a:rPr>
-              <a:t>▸  → Sree reviews like a senior engineer</a:t>
+              <a:t>▸  → Teacher reviews like a senior engineer</a:t>
             </a:r>
           </a:p>
           <a:p>
@@ -48998,7 +48998,7 @@
                   <a:srgbClr val="FFFFFF"/>
                 </a:solidFill>
               </a:rPr>
-              <a:t>▸  Sree asks 3 questions:</a:t>
+              <a:t>▸  Teacher asks 3 questions:</a:t>
             </a:r>
           </a:p>
           <a:p>
@@ -51979,7 +51979,7 @@
                   <a:srgbClr val="FFFFFF"/>
                 </a:solidFill>
               </a:rPr>
-              <a:t>▸  Advaith enters engineering when it is being reinvented. No habits to unlearn.</a:t>
+              <a:t>▸  Student enters engineering when it is being reinvented. No habits to unlearn.</a:t>
             </a:r>
           </a:p>
         </p:txBody>
@@ -53446,7 +53446,7 @@
                   <a:srgbClr val="CCCCDD"/>
                 </a:solidFill>
               </a:rPr>
-              <a:t>Sree: 'She wrote an algorithm for a machine that didn't fully exist yet. What does that tell you about the relationship between ideas and technology?'</a:t>
+              <a:t>Teacher: 'She wrote an algorithm for a machine that didn't fully exist yet. What does that tell you about the relationship between ideas and technology?'</a:t>
             </a:r>
           </a:p>
         </p:txBody>
@@ -53755,7 +53755,7 @@
                   <a:srgbClr val="FFFFFF"/>
                 </a:solidFill>
               </a:rPr>
-              <a:t>At the start of this curriculum, Advaith had never written a line of code.
+              <a:t>At the start of this curriculum, Student had never written a line of code.
 By Demo Day, he can sit down at a keyboard, build a Python program that
 downloads real data, computes statistics, plots charts, and calls an AI API —
 and explain every single line he wrote.</a:t>
@@ -54243,7 +54243,7 @@
                   <a:srgbClr val="FFD700"/>
                 </a:solidFill>
               </a:rPr>
-              <a:t>⚽  🏀  Let's go, Advaith.</a:t>
+              <a:t>⚽  🏀  Let's go, Student.</a:t>
             </a:r>
           </a:p>
         </p:txBody>
@@ -59334,7 +59334,7 @@
                   <a:srgbClr val="FFFFFF"/>
                 </a:solidFill>
               </a:rPr>
-              <a:t>🌍  The Imitation Game (2014 film) tells his story. Advaith's homework: watch it.</a:t>
+              <a:t>🌍  The Imitation Game (2014 film) tells his story. the student's homework: watch it.</a:t>
             </a:r>
           </a:p>
         </p:txBody>

</xml_diff>